<commit_message>
Fill in the video pages, and mine the last two videos
</commit_message>
<xml_diff>
--- a/Attachment-Knowledge-Graph.pptx
+++ b/Attachment-Knowledge-Graph.pptx
@@ -352,10 +352,10 @@
               <c:numCache>
                 <c:ptCount val="3"/>
                 <c:pt idx="0">
-                  <c:v>402</c:v>
+                  <c:v>426</c:v>
                 </c:pt>
                 <c:pt idx="1">
-                  <c:v>101</c:v>
+                  <c:v>103</c:v>
                 </c:pt>
                 <c:pt idx="2">
                   <c:v>33</c:v>
@@ -4007,7 +4007,7 @@
                 <a:ea typeface="Cambria" pitchFamily="34" charset="-122"/>
                 <a:cs typeface="Cambria" pitchFamily="34" charset="-120"/>
               </a:rPr>
-              <a:t>590</a:t>
+              <a:t>616</a:t>
             </a:r>
             <a:endParaRPr lang="en-US" sz="3400" dirty="0"/>
           </a:p>
@@ -4085,7 +4085,7 @@
                 <a:ea typeface="Cambria" pitchFamily="34" charset="-122"/>
                 <a:cs typeface="Cambria" pitchFamily="34" charset="-120"/>
               </a:rPr>
-              <a:t>2290</a:t>
+              <a:t>2411</a:t>
             </a:r>
             <a:endParaRPr lang="en-US" sz="3400" dirty="0"/>
           </a:p>
@@ -9596,7 +9596,7 @@
                 <a:ea typeface="Calibri" pitchFamily="34" charset="-122"/>
                 <a:cs typeface="Calibri" pitchFamily="34" charset="-120"/>
               </a:rPr>
-              <a:t>364 mirror edges. None of them says who is which.</a:t>
+              <a:t>374 mirror edges. None of them says who is which.</a:t>
             </a:r>
             <a:endParaRPr lang="en-US" sz="1200" dirty="0"/>
           </a:p>
@@ -11647,7 +11647,7 @@
                 <a:ea typeface="Calibri" pitchFamily="34" charset="-122"/>
                 <a:cs typeface="Calibri" pitchFamily="34" charset="-120"/>
               </a:rPr>
-              <a:t>Consciously Adapting To Each Relationship</a:t>
+              <a:t>Talking It Out Directly</a:t>
             </a:r>
             <a:endParaRPr lang="en-US" sz="1300" dirty="0"/>
           </a:p>
@@ -11689,7 +11689,7 @@
                 <a:ea typeface="Calibri" pitchFamily="34" charset="-122"/>
                 <a:cs typeface="Calibri" pitchFamily="34" charset="-120"/>
               </a:rPr>
-              <a:t>Feeling avoidant around some people and anxious around others is not evidence of fearful-avoidance — most people pull back a little from a surplus of anxious energy and lean in a little toward…</a:t>
+              <a:t>The drama triangle is what you do when a need cannot be stated outright.</a:t>
             </a:r>
             <a:endParaRPr lang="en-US" sz="1150" dirty="0"/>
           </a:p>
@@ -11756,7 +11756,7 @@
                 <a:ea typeface="Calibri" pitchFamily="34" charset="-122"/>
                 <a:cs typeface="Calibri" pitchFamily="34" charset="-120"/>
               </a:rPr>
-              <a:t>Not Taking Moods Personally</a:t>
+              <a:t>Consciously Adapting To Each Relationship</a:t>
             </a:r>
             <a:endParaRPr lang="en-US" sz="1300" dirty="0"/>
           </a:p>
@@ -11798,7 +11798,7 @@
                 <a:ea typeface="Calibri" pitchFamily="34" charset="-122"/>
                 <a:cs typeface="Calibri" pitchFamily="34" charset="-120"/>
               </a:rPr>
-              <a:t>There are two ways to take a mood personally: reading it as rejection, or being irritated that someone is displaying what you have learned to suppress.</a:t>
+              <a:t>Feeling avoidant around some people and anxious around others is not evidence of fearful-avoidance — most people pull back a little from a surplus of anxious energy and lean in a little toward…</a:t>
             </a:r>
             <a:endParaRPr lang="en-US" sz="1150" dirty="0"/>
           </a:p>
@@ -11865,7 +11865,7 @@
                 <a:ea typeface="Calibri" pitchFamily="34" charset="-122"/>
                 <a:cs typeface="Calibri" pitchFamily="34" charset="-120"/>
               </a:rPr>
-              <a:t>Letting The Pain Land</a:t>
+              <a:t>Healthy Dependency</a:t>
             </a:r>
             <a:endParaRPr lang="en-US" sz="1300" dirty="0"/>
           </a:p>
@@ -11907,7 +11907,7 @@
                 <a:ea typeface="Calibri" pitchFamily="34" charset="-122"/>
                 <a:cs typeface="Calibri" pitchFamily="34" charset="-120"/>
               </a:rPr>
-              <a:t>A sign of change: registering the cost of an interaction while it is happening rather than reconstructing it later without the charge.</a:t>
+              <a:t>Total dependency is a problem; so is refusing to rely on anyone for anything.</a:t>
             </a:r>
             <a:endParaRPr lang="en-US" sz="1150" dirty="0"/>
           </a:p>
@@ -11974,7 +11974,7 @@
                 <a:ea typeface="Calibri" pitchFamily="34" charset="-122"/>
                 <a:cs typeface="Calibri" pitchFamily="34" charset="-120"/>
               </a:rPr>
-              <a:t>Naming The Fantasy</a:t>
+              <a:t>Meaningful Goals And Collaboration</a:t>
             </a:r>
             <a:endParaRPr lang="en-US" sz="1300" dirty="0"/>
           </a:p>
@@ -12016,7 +12016,7 @@
                 <a:ea typeface="Calibri" pitchFamily="34" charset="-122"/>
                 <a:cs typeface="Calibri" pitchFamily="34" charset="-120"/>
               </a:rPr>
-              <a:t>A sign of change: spotting the invented version while it is running, and letting the real person be disappointing rather than treating the gap as something they owe you.</a:t>
+              <a:t>Setting a goal that means something needs both faculties: the emotional one that knows what speaks to you, and the practical one that knows what makes sense.</a:t>
             </a:r>
             <a:endParaRPr lang="en-US" sz="1150" dirty="0"/>
           </a:p>
@@ -12083,7 +12083,7 @@
                 <a:ea typeface="Calibri" pitchFamily="34" charset="-122"/>
                 <a:cs typeface="Calibri" pitchFamily="34" charset="-120"/>
               </a:rPr>
-              <a:t>Recognizing Your Own Vulnerability</a:t>
+              <a:t>Not Taking Moods Personally</a:t>
             </a:r>
             <a:endParaRPr lang="en-US" sz="1300" dirty="0"/>
           </a:p>
@@ -12125,7 +12125,7 @@
                 <a:ea typeface="Calibri" pitchFamily="34" charset="-122"/>
                 <a:cs typeface="Calibri" pitchFamily="34" charset="-120"/>
               </a:rPr>
-              <a:t>A sign of change: locating the places, past or present, where you needed care and did not get it — without first requiring a justification for why it counts.</a:t>
+              <a:t>There are two ways to take a mood personally: reading it as rejection, or being irritated that someone is displaying what you have learned to suppress.</a:t>
             </a:r>
             <a:endParaRPr lang="en-US" sz="1150" dirty="0"/>
           </a:p>
@@ -18885,7 +18885,7 @@
                 <a:ea typeface="Calibri" pitchFamily="34" charset="-122"/>
                 <a:cs typeface="Calibri" pitchFamily="34" charset="-120"/>
               </a:rPr>
-              <a:t>101 nodes marked "literature" are unverified</a:t>
+              <a:t>103 nodes marked "literature" are unverified</a:t>
             </a:r>
             <a:endParaRPr lang="en-US" sz="1300" dirty="0"/>
           </a:p>
@@ -19412,7 +19412,7 @@
                 <a:ea typeface="Calibri" pitchFamily="34" charset="-122"/>
                 <a:cs typeface="Calibri" pitchFamily="34" charset="-120"/>
               </a:rPr>
-              <a:t>Check the 101 nodes marked "literature" against the primary sources, and record the result separately from where the idea came from.</a:t>
+              <a:t>Check the 103 nodes marked "literature" against the primary sources, and record the result separately from where the idea came from.</a:t>
             </a:r>
             <a:endParaRPr lang="en-US" sz="1150" dirty="0"/>
           </a:p>
@@ -21456,7 +21456,7 @@
                 <a:ea typeface="Cambria" pitchFamily="34" charset="-122"/>
                 <a:cs typeface="Cambria" pitchFamily="34" charset="-120"/>
               </a:rPr>
-              <a:t>590</a:t>
+              <a:t>616</a:t>
             </a:r>
             <a:endParaRPr lang="en-US" sz="3600" dirty="0"/>
           </a:p>
@@ -21557,7 +21557,7 @@
                 <a:ea typeface="Cambria" pitchFamily="34" charset="-122"/>
                 <a:cs typeface="Cambria" pitchFamily="34" charset="-120"/>
               </a:rPr>
-              <a:t>2290</a:t>
+              <a:t>2411</a:t>
             </a:r>
             <a:endParaRPr lang="en-US" sz="3600" dirty="0"/>
           </a:p>
@@ -23275,7 +23275,7 @@
                 <a:ea typeface="Calibri" pitchFamily="34" charset="-122"/>
                 <a:cs typeface="Calibri" pitchFamily="34" charset="-120"/>
               </a:rPr>
-              <a:t>   26</a:t>
+              <a:t>   29</a:t>
             </a:r>
             <a:endParaRPr lang="en-US" sz="1400" dirty="0"/>
           </a:p>
@@ -23395,7 +23395,7 @@
                 <a:ea typeface="Calibri" pitchFamily="34" charset="-122"/>
                 <a:cs typeface="Calibri" pitchFamily="34" charset="-120"/>
               </a:rPr>
-              <a:t>   21</a:t>
+              <a:t>   23</a:t>
             </a:r>
             <a:endParaRPr lang="en-US" sz="1400" dirty="0"/>
           </a:p>
@@ -23515,7 +23515,7 @@
                 <a:ea typeface="Calibri" pitchFamily="34" charset="-122"/>
                 <a:cs typeface="Calibri" pitchFamily="34" charset="-120"/>
               </a:rPr>
-              <a:t>   51</a:t>
+              <a:t>   54</a:t>
             </a:r>
             <a:endParaRPr lang="en-US" sz="1400" dirty="0"/>
           </a:p>
@@ -23635,7 +23635,7 @@
                 <a:ea typeface="Calibri" pitchFamily="34" charset="-122"/>
                 <a:cs typeface="Calibri" pitchFamily="34" charset="-120"/>
               </a:rPr>
-              <a:t>   58</a:t>
+              <a:t>   61</a:t>
             </a:r>
             <a:endParaRPr lang="en-US" sz="1400" dirty="0"/>
           </a:p>
@@ -23995,7 +23995,7 @@
                 <a:ea typeface="Calibri" pitchFamily="34" charset="-122"/>
                 <a:cs typeface="Calibri" pitchFamily="34" charset="-120"/>
               </a:rPr>
-              <a:t>   245</a:t>
+              <a:t>   259</a:t>
             </a:r>
             <a:endParaRPr lang="en-US" sz="1400" dirty="0"/>
           </a:p>
@@ -24115,7 +24115,7 @@
                 <a:ea typeface="Calibri" pitchFamily="34" charset="-122"/>
                 <a:cs typeface="Calibri" pitchFamily="34" charset="-120"/>
               </a:rPr>
-              <a:t>   93</a:t>
+              <a:t>   94</a:t>
             </a:r>
             <a:endParaRPr lang="en-US" sz="1400" dirty="0"/>
           </a:p>
@@ -24810,7 +24810,7 @@
                 <a:ea typeface="Calibri" pitchFamily="34" charset="-122"/>
                 <a:cs typeface="Calibri" pitchFamily="34" charset="-120"/>
               </a:rPr>
-              <a:t>35</a:t>
+              <a:t>36</a:t>
             </a:r>
             <a:endParaRPr lang="en-US" sz="900" dirty="0"/>
           </a:p>
@@ -25020,7 +25020,7 @@
                 <a:ea typeface="Calibri" pitchFamily="34" charset="-122"/>
                 <a:cs typeface="Calibri" pitchFamily="34" charset="-120"/>
               </a:rPr>
-              <a:t>77</a:t>
+              <a:t>78</a:t>
             </a:r>
             <a:endParaRPr lang="en-US" sz="900" dirty="0"/>
           </a:p>
@@ -25203,7 +25203,7 @@
                 <a:ea typeface="Calibri" pitchFamily="34" charset="-122"/>
                 <a:cs typeface="Calibri" pitchFamily="34" charset="-120"/>
               </a:rPr>
-              <a:t>14</a:t>
+              <a:t>15</a:t>
             </a:r>
             <a:endParaRPr lang="en-US" sz="900" dirty="0"/>
           </a:p>
@@ -25308,7 +25308,7 @@
                 <a:ea typeface="Calibri" pitchFamily="34" charset="-122"/>
                 <a:cs typeface="Calibri" pitchFamily="34" charset="-120"/>
               </a:rPr>
-              <a:t>32</a:t>
+              <a:t>34</a:t>
             </a:r>
             <a:endParaRPr lang="en-US" sz="900" dirty="0"/>
           </a:p>
@@ -25413,7 +25413,7 @@
                 <a:ea typeface="Calibri" pitchFamily="34" charset="-122"/>
                 <a:cs typeface="Calibri" pitchFamily="34" charset="-120"/>
               </a:rPr>
-              <a:t>53</a:t>
+              <a:t>56</a:t>
             </a:r>
             <a:endParaRPr lang="en-US" sz="900" dirty="0"/>
           </a:p>
@@ -25518,7 +25518,7 @@
                 <a:ea typeface="Calibri" pitchFamily="34" charset="-122"/>
                 <a:cs typeface="Calibri" pitchFamily="34" charset="-120"/>
               </a:rPr>
-              <a:t>48</a:t>
+              <a:t>60</a:t>
             </a:r>
             <a:endParaRPr lang="en-US" sz="900" dirty="0"/>
           </a:p>
@@ -25701,7 +25701,7 @@
                 <a:ea typeface="Calibri" pitchFamily="34" charset="-122"/>
                 <a:cs typeface="Calibri" pitchFamily="34" charset="-120"/>
               </a:rPr>
-              <a:t>207</a:t>
+              <a:t>224</a:t>
             </a:r>
             <a:endParaRPr lang="en-US" sz="900" dirty="0"/>
           </a:p>
@@ -25806,7 +25806,7 @@
                 <a:ea typeface="Calibri" pitchFamily="34" charset="-122"/>
                 <a:cs typeface="Calibri" pitchFamily="34" charset="-120"/>
               </a:rPr>
-              <a:t>364</a:t>
+              <a:t>374</a:t>
             </a:r>
             <a:endParaRPr lang="en-US" sz="900" dirty="0"/>
           </a:p>
@@ -25911,7 +25911,7 @@
                 <a:ea typeface="Calibri" pitchFamily="34" charset="-122"/>
                 <a:cs typeface="Calibri" pitchFamily="34" charset="-120"/>
               </a:rPr>
-              <a:t>498</a:t>
+              <a:t>520</a:t>
             </a:r>
             <a:endParaRPr lang="en-US" sz="900" dirty="0"/>
           </a:p>
@@ -26016,7 +26016,7 @@
                 <a:ea typeface="Calibri" pitchFamily="34" charset="-122"/>
                 <a:cs typeface="Calibri" pitchFamily="34" charset="-120"/>
               </a:rPr>
-              <a:t>30</a:t>
+              <a:t>34</a:t>
             </a:r>
             <a:endParaRPr lang="en-US" sz="900" dirty="0"/>
           </a:p>
@@ -26121,7 +26121,7 @@
                 <a:ea typeface="Calibri" pitchFamily="34" charset="-122"/>
                 <a:cs typeface="Calibri" pitchFamily="34" charset="-120"/>
               </a:rPr>
-              <a:t>192</a:t>
+              <a:t>209</a:t>
             </a:r>
             <a:endParaRPr lang="en-US" sz="900" dirty="0"/>
           </a:p>
@@ -26304,7 +26304,7 @@
                 <a:ea typeface="Calibri" pitchFamily="34" charset="-122"/>
                 <a:cs typeface="Calibri" pitchFamily="34" charset="-120"/>
               </a:rPr>
-              <a:t>84</a:t>
+              <a:t>88</a:t>
             </a:r>
             <a:endParaRPr lang="en-US" sz="900" dirty="0"/>
           </a:p>
@@ -26409,7 +26409,7 @@
                 <a:ea typeface="Calibri" pitchFamily="34" charset="-122"/>
                 <a:cs typeface="Calibri" pitchFamily="34" charset="-120"/>
               </a:rPr>
-              <a:t>86</a:t>
+              <a:t>87</a:t>
             </a:r>
             <a:endParaRPr lang="en-US" sz="900" dirty="0"/>
           </a:p>
@@ -26592,7 +26592,7 @@
                 <a:ea typeface="Calibri" pitchFamily="34" charset="-122"/>
                 <a:cs typeface="Calibri" pitchFamily="34" charset="-120"/>
               </a:rPr>
-              <a:t>542</a:t>
+              <a:t>568</a:t>
             </a:r>
             <a:endParaRPr lang="en-US" sz="900" dirty="0"/>
           </a:p>

</xml_diff>